<commit_message>
Increase LLM timeout to 300s for large Hebrew documents
Hebrew ISO documents take longer to process with GPT-oss-20b.
Increased timeout from 180s to 300s to match route timeout.

This prevents Bad Gateway errors during Hebrew document parsing.

Co-Authored-By: Claude Sonnet 4.5 <noreply@anthropic.com>
</commit_message>
<xml_diff>
--- a/docs/ppts/Enterprise_AI_Platform_RHOAI  -  final.pptx
+++ b/docs/ppts/Enterprise_AI_Platform_RHOAI  -  final.pptx
@@ -10,11 +10,11 @@
   <p:sldIdLst>
     <p:sldId id="256" r:id="rId2"/>
     <p:sldId id="267" r:id="rId3"/>
-    <p:sldId id="258" r:id="rId4"/>
-    <p:sldId id="259" r:id="rId5"/>
-    <p:sldId id="264" r:id="rId6"/>
-    <p:sldId id="266" r:id="rId7"/>
-    <p:sldId id="261" r:id="rId8"/>
+    <p:sldId id="261" r:id="rId4"/>
+    <p:sldId id="264" r:id="rId5"/>
+    <p:sldId id="258" r:id="rId6"/>
+    <p:sldId id="259" r:id="rId7"/>
+    <p:sldId id="266" r:id="rId8"/>
     <p:sldId id="262" r:id="rId9"/>
     <p:sldId id="263" r:id="rId10"/>
     <p:sldId id="265" r:id="rId11"/>
@@ -5531,8 +5531,8 @@
         </p:nvSpPr>
         <p:spPr>
           <a:xfrm>
-            <a:off x="2730861" y="45720"/>
-            <a:ext cx="6425477" cy="523220"/>
+            <a:off x="1673138" y="45720"/>
+            <a:ext cx="8540928" cy="523220"/>
           </a:xfrm>
           <a:prstGeom prst="rect">
             <a:avLst/>
@@ -5553,6 +5553,11 @@
               </a:defRPr>
             </a:pPr>
             <a:r>
+              <a:rPr lang="en-US" dirty="0"/>
+              <a:t>Business case: </a:t>
+            </a:r>
+            <a:r>
+              <a:rPr dirty="0"/>
               <a:t>AI-Powered ISO Compliance Management</a:t>
             </a:r>
           </a:p>
@@ -6301,8 +6306,8 @@
         </p:nvSpPr>
         <p:spPr>
           <a:xfrm>
-            <a:off x="0" y="0"/>
-            <a:ext cx="12188825" cy="666974"/>
+            <a:off x="0" y="-1"/>
+            <a:ext cx="12188825" cy="618565"/>
           </a:xfrm>
           <a:prstGeom prst="rect">
             <a:avLst/>
@@ -6345,8 +6350,8 @@
         </p:nvSpPr>
         <p:spPr>
           <a:xfrm>
-            <a:off x="457199" y="45720"/>
-            <a:ext cx="11310258" cy="523220"/>
+            <a:off x="1227506" y="45720"/>
+            <a:ext cx="9432198" cy="523220"/>
           </a:xfrm>
           <a:prstGeom prst="rect">
             <a:avLst/>
@@ -6354,7 +6359,7 @@
           <a:noFill/>
         </p:spPr>
         <p:txBody>
-          <a:bodyPr wrap="square">
+          <a:bodyPr wrap="none">
             <a:spAutoFit/>
           </a:bodyPr>
           <a:lstStyle/>
@@ -6367,655 +6372,44 @@
               </a:defRPr>
             </a:pPr>
             <a:r>
-              <a:rPr dirty="0"/>
-              <a:t>Architecture</a:t>
-            </a:r>
-            <a:r>
-              <a:rPr lang="en-US" dirty="0"/>
-              <a:t> layers</a:t>
+              <a:rPr lang="en-IL" sz="2800" b="1" dirty="0"/>
+              <a:t>ISO Compliance AI Platform — Architecture (OpenShift Flavor)</a:t>
             </a:r>
             <a:endParaRPr dirty="0"/>
           </a:p>
         </p:txBody>
       </p:sp>
-      <p:sp>
-        <p:nvSpPr>
-          <p:cNvPr id="4" name="Rectangle 3"/>
-          <p:cNvSpPr/>
-          <p:nvPr/>
-        </p:nvSpPr>
-        <p:spPr>
-          <a:xfrm>
-            <a:off x="1385047" y="1344706"/>
-            <a:ext cx="9144000" cy="731520"/>
+      <p:pic>
+        <p:nvPicPr>
+          <p:cNvPr id="10" name="Picture 9">
+            <a:extLst>
+              <a:ext uri="{FF2B5EF4-FFF2-40B4-BE49-F238E27FC236}">
+                <a16:creationId xmlns:a16="http://schemas.microsoft.com/office/drawing/2014/main" id="{3DCC8C8A-2D8D-0284-E188-08A8AC5A2AD9}"/>
+              </a:ext>
+            </a:extLst>
+          </p:cNvPr>
+          <p:cNvPicPr>
+            <a:picLocks noChangeAspect="1"/>
+          </p:cNvPicPr>
+          <p:nvPr/>
+        </p:nvPicPr>
+        <p:blipFill>
+          <a:blip r:embed="rId2"/>
+          <a:srcRect t="6358"/>
+          <a:stretch>
+            <a:fillRect/>
+          </a:stretch>
+        </p:blipFill>
+        <p:spPr>
+          <a:xfrm>
+            <a:off x="1120660" y="762256"/>
+            <a:ext cx="9947503" cy="5864533"/>
           </a:xfrm>
           <a:prstGeom prst="rect">
             <a:avLst/>
           </a:prstGeom>
-          <a:solidFill>
-            <a:srgbClr val="0066CC"/>
-          </a:solidFill>
-          <a:ln>
-            <a:solidFill>
-              <a:srgbClr val="0066CC"/>
-            </a:solidFill>
-          </a:ln>
-        </p:spPr>
-        <p:style>
-          <a:lnRef idx="1">
-            <a:schemeClr val="accent1"/>
-          </a:lnRef>
-          <a:fillRef idx="3">
-            <a:schemeClr val="accent1"/>
-          </a:fillRef>
-          <a:effectRef idx="2">
-            <a:schemeClr val="accent1"/>
-          </a:effectRef>
-          <a:fontRef idx="minor">
-            <a:schemeClr val="lt1"/>
-          </a:fontRef>
-        </p:style>
-        <p:txBody>
-          <a:bodyPr rtlCol="0" anchor="ctr"/>
-          <a:lstStyle/>
-          <a:p>
-            <a:pPr algn="ctr"/>
-            <a:endParaRPr/>
-          </a:p>
-        </p:txBody>
-      </p:sp>
-      <p:sp>
-        <p:nvSpPr>
-          <p:cNvPr id="5" name="TextBox 4"/>
-          <p:cNvSpPr txBox="1"/>
-          <p:nvPr/>
-        </p:nvSpPr>
-        <p:spPr>
-          <a:xfrm>
-            <a:off x="1567927" y="1436146"/>
-            <a:ext cx="2743200" cy="548640"/>
-          </a:xfrm>
-          <a:prstGeom prst="rect">
-            <a:avLst/>
-          </a:prstGeom>
-          <a:noFill/>
-        </p:spPr>
-        <p:txBody>
-          <a:bodyPr wrap="none" anchor="ctr">
-            <a:spAutoFit/>
-          </a:bodyPr>
-          <a:lstStyle/>
-          <a:p>
-            <a:pPr>
-              <a:defRPr sz="2000" b="1">
-                <a:solidFill>
-                  <a:srgbClr val="FFFFFF"/>
-                </a:solidFill>
-              </a:defRPr>
-            </a:pPr>
-            <a:r>
-              <a:t>Application Layer</a:t>
-            </a:r>
-          </a:p>
-        </p:txBody>
-      </p:sp>
-      <p:sp>
-        <p:nvSpPr>
-          <p:cNvPr id="6" name="TextBox 5"/>
-          <p:cNvSpPr txBox="1"/>
-          <p:nvPr/>
-        </p:nvSpPr>
-        <p:spPr>
-          <a:xfrm>
-            <a:off x="4585447" y="1556577"/>
-            <a:ext cx="4143635" cy="307777"/>
-          </a:xfrm>
-          <a:prstGeom prst="rect">
-            <a:avLst/>
-          </a:prstGeom>
-          <a:noFill/>
-        </p:spPr>
-        <p:txBody>
-          <a:bodyPr wrap="none" anchor="ctr">
-            <a:spAutoFit/>
-          </a:bodyPr>
-          <a:lstStyle/>
-          <a:p>
-            <a:pPr>
-              <a:defRPr sz="1400">
-                <a:solidFill>
-                  <a:srgbClr val="FFFFFF"/>
-                </a:solidFill>
-              </a:defRPr>
-            </a:pPr>
-            <a:r>
-              <a:rPr dirty="0"/>
-              <a:t>iso-web  ·  iso-</a:t>
-            </a:r>
-            <a:r>
-              <a:rPr dirty="0" err="1"/>
-              <a:t>api</a:t>
-            </a:r>
-            <a:r>
-              <a:rPr dirty="0"/>
-              <a:t>  ·  AI Playground</a:t>
-            </a:r>
-            <a:r>
-              <a:rPr lang="en-IL" dirty="0"/>
-              <a:t> · functioonal agents</a:t>
-            </a:r>
-            <a:endParaRPr dirty="0"/>
-          </a:p>
-        </p:txBody>
-      </p:sp>
-      <p:sp>
-        <p:nvSpPr>
-          <p:cNvPr id="7" name="Rectangle 6"/>
-          <p:cNvSpPr/>
-          <p:nvPr/>
-        </p:nvSpPr>
-        <p:spPr>
-          <a:xfrm>
-            <a:off x="1385047" y="2460170"/>
-            <a:ext cx="9144000" cy="896215"/>
-          </a:xfrm>
-          <a:prstGeom prst="rect">
-            <a:avLst/>
-          </a:prstGeom>
-          <a:solidFill>
-            <a:srgbClr val="7030A0"/>
-          </a:solidFill>
-          <a:ln>
-            <a:solidFill>
-              <a:srgbClr val="7030A0"/>
-            </a:solidFill>
-          </a:ln>
-        </p:spPr>
-        <p:style>
-          <a:lnRef idx="1">
-            <a:schemeClr val="accent1"/>
-          </a:lnRef>
-          <a:fillRef idx="3">
-            <a:schemeClr val="accent1"/>
-          </a:fillRef>
-          <a:effectRef idx="2">
-            <a:schemeClr val="accent1"/>
-          </a:effectRef>
-          <a:fontRef idx="minor">
-            <a:schemeClr val="lt1"/>
-          </a:fontRef>
-        </p:style>
-        <p:txBody>
-          <a:bodyPr rtlCol="0" anchor="ctr"/>
-          <a:lstStyle/>
-          <a:p>
-            <a:pPr algn="ctr"/>
-            <a:endParaRPr/>
-          </a:p>
-        </p:txBody>
-      </p:sp>
-      <p:sp>
-        <p:nvSpPr>
-          <p:cNvPr id="8" name="TextBox 7"/>
-          <p:cNvSpPr txBox="1"/>
-          <p:nvPr/>
-        </p:nvSpPr>
-        <p:spPr>
-          <a:xfrm>
-            <a:off x="1567927" y="2350546"/>
-            <a:ext cx="2743200" cy="914400"/>
-          </a:xfrm>
-          <a:prstGeom prst="rect">
-            <a:avLst/>
-          </a:prstGeom>
-          <a:noFill/>
-        </p:spPr>
-        <p:txBody>
-          <a:bodyPr wrap="none" anchor="ctr">
-            <a:spAutoFit/>
-          </a:bodyPr>
-          <a:lstStyle/>
-          <a:p>
-            <a:pPr>
-              <a:defRPr sz="2000" b="1">
-                <a:solidFill>
-                  <a:srgbClr val="FFFFFF"/>
-                </a:solidFill>
-              </a:defRPr>
-            </a:pPr>
-            <a:r>
-              <a:t>Model as a Service</a:t>
-            </a:r>
-          </a:p>
-        </p:txBody>
-      </p:sp>
-      <p:sp>
-        <p:nvSpPr>
-          <p:cNvPr id="9" name="TextBox 8"/>
-          <p:cNvSpPr txBox="1"/>
-          <p:nvPr/>
-        </p:nvSpPr>
-        <p:spPr>
-          <a:xfrm>
-            <a:off x="4585447" y="2350546"/>
-            <a:ext cx="5486400" cy="914400"/>
-          </a:xfrm>
-          <a:prstGeom prst="rect">
-            <a:avLst/>
-          </a:prstGeom>
-          <a:noFill/>
-        </p:spPr>
-        <p:txBody>
-          <a:bodyPr wrap="none" anchor="ctr">
-            <a:spAutoFit/>
-          </a:bodyPr>
-          <a:lstStyle/>
-          <a:p>
-            <a:pPr>
-              <a:defRPr sz="1400">
-                <a:solidFill>
-                  <a:srgbClr val="FFFFFF"/>
-                </a:solidFill>
-              </a:defRPr>
-            </a:pPr>
-            <a:r>
-              <a:rPr dirty="0"/>
-              <a:t>GPT-oss-20b (21B </a:t>
-            </a:r>
-            <a:r>
-              <a:rPr dirty="0" err="1"/>
-              <a:t>MoE</a:t>
-            </a:r>
-            <a:r>
-              <a:rPr dirty="0"/>
-              <a:t>)  ·  BGE-M3 Embeddings  ·  Qwen3-4B</a:t>
-            </a:r>
-          </a:p>
-        </p:txBody>
-      </p:sp>
-      <p:sp>
-        <p:nvSpPr>
-          <p:cNvPr id="10" name="Rectangle 9"/>
-          <p:cNvSpPr/>
-          <p:nvPr/>
-        </p:nvSpPr>
-        <p:spPr>
-          <a:xfrm>
-            <a:off x="1385047" y="4453666"/>
-            <a:ext cx="9144000" cy="731520"/>
-          </a:xfrm>
-          <a:prstGeom prst="rect">
-            <a:avLst/>
-          </a:prstGeom>
-          <a:solidFill>
-            <a:srgbClr val="92D050"/>
-          </a:solidFill>
-          <a:ln>
-            <a:solidFill>
-              <a:srgbClr val="92D050"/>
-            </a:solidFill>
-          </a:ln>
-        </p:spPr>
-        <p:style>
-          <a:lnRef idx="1">
-            <a:schemeClr val="accent1"/>
-          </a:lnRef>
-          <a:fillRef idx="3">
-            <a:schemeClr val="accent1"/>
-          </a:fillRef>
-          <a:effectRef idx="2">
-            <a:schemeClr val="accent1"/>
-          </a:effectRef>
-          <a:fontRef idx="minor">
-            <a:schemeClr val="lt1"/>
-          </a:fontRef>
-        </p:style>
-        <p:txBody>
-          <a:bodyPr rtlCol="0" anchor="ctr"/>
-          <a:lstStyle/>
-          <a:p>
-            <a:pPr algn="ctr"/>
-            <a:endParaRPr/>
-          </a:p>
-        </p:txBody>
-      </p:sp>
-      <p:sp>
-        <p:nvSpPr>
-          <p:cNvPr id="11" name="TextBox 10"/>
-          <p:cNvSpPr txBox="1"/>
-          <p:nvPr/>
-        </p:nvSpPr>
-        <p:spPr>
-          <a:xfrm>
-            <a:off x="1567927" y="4545106"/>
-            <a:ext cx="2743200" cy="548640"/>
-          </a:xfrm>
-          <a:prstGeom prst="rect">
-            <a:avLst/>
-          </a:prstGeom>
-          <a:noFill/>
-        </p:spPr>
-        <p:txBody>
-          <a:bodyPr wrap="none" anchor="ctr">
-            <a:spAutoFit/>
-          </a:bodyPr>
-          <a:lstStyle/>
-          <a:p>
-            <a:pPr>
-              <a:defRPr sz="2000" b="1">
-                <a:solidFill>
-                  <a:srgbClr val="FFFFFF"/>
-                </a:solidFill>
-              </a:defRPr>
-            </a:pPr>
-            <a:r>
-              <a:t>Inference &amp; Serving</a:t>
-            </a:r>
-          </a:p>
-        </p:txBody>
-      </p:sp>
-      <p:sp>
-        <p:nvSpPr>
-          <p:cNvPr id="12" name="TextBox 11"/>
-          <p:cNvSpPr txBox="1"/>
-          <p:nvPr/>
-        </p:nvSpPr>
-        <p:spPr>
-          <a:xfrm>
-            <a:off x="4585447" y="4665537"/>
-            <a:ext cx="2994859" cy="307777"/>
-          </a:xfrm>
-          <a:prstGeom prst="rect">
-            <a:avLst/>
-          </a:prstGeom>
-          <a:noFill/>
-        </p:spPr>
-        <p:txBody>
-          <a:bodyPr wrap="none" anchor="ctr">
-            <a:spAutoFit/>
-          </a:bodyPr>
-          <a:lstStyle/>
-          <a:p>
-            <a:pPr>
-              <a:defRPr sz="1400">
-                <a:solidFill>
-                  <a:srgbClr val="FFFFFF"/>
-                </a:solidFill>
-              </a:defRPr>
-            </a:pPr>
-            <a:r>
-              <a:rPr dirty="0" err="1"/>
-              <a:t>KServe</a:t>
-            </a:r>
-            <a:r>
-              <a:rPr dirty="0"/>
-              <a:t>  ·  </a:t>
-            </a:r>
-            <a:r>
-              <a:rPr dirty="0" err="1"/>
-              <a:t>vLLM</a:t>
-            </a:r>
-            <a:r>
-              <a:rPr dirty="0"/>
-              <a:t>  ·  </a:t>
-            </a:r>
-            <a:r>
-              <a:rPr dirty="0" err="1"/>
-              <a:t>LLMInferenceService</a:t>
-            </a:r>
-            <a:endParaRPr dirty="0"/>
-          </a:p>
-        </p:txBody>
-      </p:sp>
-      <p:sp>
-        <p:nvSpPr>
-          <p:cNvPr id="13" name="Rectangle 12"/>
-          <p:cNvSpPr/>
-          <p:nvPr/>
-        </p:nvSpPr>
-        <p:spPr>
-          <a:xfrm>
-            <a:off x="1385047" y="3539266"/>
-            <a:ext cx="9144000" cy="731520"/>
-          </a:xfrm>
-          <a:prstGeom prst="rect">
-            <a:avLst/>
-          </a:prstGeom>
-          <a:solidFill>
-            <a:srgbClr val="FFC000"/>
-          </a:solidFill>
-          <a:ln>
-            <a:solidFill>
-              <a:srgbClr val="FFC000"/>
-            </a:solidFill>
-          </a:ln>
-        </p:spPr>
-        <p:style>
-          <a:lnRef idx="1">
-            <a:schemeClr val="accent1"/>
-          </a:lnRef>
-          <a:fillRef idx="3">
-            <a:schemeClr val="accent1"/>
-          </a:fillRef>
-          <a:effectRef idx="2">
-            <a:schemeClr val="accent1"/>
-          </a:effectRef>
-          <a:fontRef idx="minor">
-            <a:schemeClr val="lt1"/>
-          </a:fontRef>
-        </p:style>
-        <p:txBody>
-          <a:bodyPr rtlCol="0" anchor="ctr"/>
-          <a:lstStyle/>
-          <a:p>
-            <a:pPr algn="ctr"/>
-            <a:endParaRPr/>
-          </a:p>
-        </p:txBody>
-      </p:sp>
-      <p:sp>
-        <p:nvSpPr>
-          <p:cNvPr id="14" name="TextBox 13"/>
-          <p:cNvSpPr txBox="1"/>
-          <p:nvPr/>
-        </p:nvSpPr>
-        <p:spPr>
-          <a:xfrm>
-            <a:off x="1567927" y="3630706"/>
-            <a:ext cx="2743200" cy="548640"/>
-          </a:xfrm>
-          <a:prstGeom prst="rect">
-            <a:avLst/>
-          </a:prstGeom>
-          <a:noFill/>
-        </p:spPr>
-        <p:txBody>
-          <a:bodyPr wrap="none" anchor="ctr">
-            <a:spAutoFit/>
-          </a:bodyPr>
-          <a:lstStyle/>
-          <a:p>
-            <a:pPr>
-              <a:defRPr sz="2000" b="1">
-                <a:solidFill>
-                  <a:srgbClr val="FFFFFF"/>
-                </a:solidFill>
-              </a:defRPr>
-            </a:pPr>
-            <a:r>
-              <a:t>AI Governance</a:t>
-            </a:r>
-          </a:p>
-        </p:txBody>
-      </p:sp>
-      <p:sp>
-        <p:nvSpPr>
-          <p:cNvPr id="15" name="TextBox 14"/>
-          <p:cNvSpPr txBox="1"/>
-          <p:nvPr/>
-        </p:nvSpPr>
-        <p:spPr>
-          <a:xfrm>
-            <a:off x="4585447" y="3630706"/>
-            <a:ext cx="5486400" cy="548640"/>
-          </a:xfrm>
-          <a:prstGeom prst="rect">
-            <a:avLst/>
-          </a:prstGeom>
-          <a:noFill/>
-        </p:spPr>
-        <p:txBody>
-          <a:bodyPr wrap="none" anchor="ctr">
-            <a:spAutoFit/>
-          </a:bodyPr>
-          <a:lstStyle/>
-          <a:p>
-            <a:pPr>
-              <a:defRPr sz="1400">
-                <a:solidFill>
-                  <a:srgbClr val="FFFFFF"/>
-                </a:solidFill>
-              </a:defRPr>
-            </a:pPr>
-            <a:r>
-              <a:t>TrustyAI  ·  Guardrails Orchestrator  ·  Kuadrant + Authorino</a:t>
-            </a:r>
-          </a:p>
-        </p:txBody>
-      </p:sp>
-      <p:sp>
-        <p:nvSpPr>
-          <p:cNvPr id="16" name="Rectangle 15"/>
-          <p:cNvSpPr/>
-          <p:nvPr/>
-        </p:nvSpPr>
-        <p:spPr>
-          <a:xfrm>
-            <a:off x="1385047" y="5459506"/>
-            <a:ext cx="9144000" cy="731520"/>
-          </a:xfrm>
-          <a:prstGeom prst="rect">
-            <a:avLst/>
-          </a:prstGeom>
-          <a:solidFill>
-            <a:srgbClr val="5C5C5C"/>
-          </a:solidFill>
-          <a:ln>
-            <a:solidFill>
-              <a:srgbClr val="5C5C5C"/>
-            </a:solidFill>
-          </a:ln>
-        </p:spPr>
-        <p:style>
-          <a:lnRef idx="1">
-            <a:schemeClr val="accent1"/>
-          </a:lnRef>
-          <a:fillRef idx="3">
-            <a:schemeClr val="accent1"/>
-          </a:fillRef>
-          <a:effectRef idx="2">
-            <a:schemeClr val="accent1"/>
-          </a:effectRef>
-          <a:fontRef idx="minor">
-            <a:schemeClr val="lt1"/>
-          </a:fontRef>
-        </p:style>
-        <p:txBody>
-          <a:bodyPr rtlCol="0" anchor="ctr"/>
-          <a:lstStyle/>
-          <a:p>
-            <a:pPr algn="ctr"/>
-            <a:endParaRPr/>
-          </a:p>
-        </p:txBody>
-      </p:sp>
-      <p:sp>
-        <p:nvSpPr>
-          <p:cNvPr id="17" name="TextBox 16"/>
-          <p:cNvSpPr txBox="1"/>
-          <p:nvPr/>
-        </p:nvSpPr>
-        <p:spPr>
-          <a:xfrm>
-            <a:off x="1567927" y="5550946"/>
-            <a:ext cx="2743200" cy="548640"/>
-          </a:xfrm>
-          <a:prstGeom prst="rect">
-            <a:avLst/>
-          </a:prstGeom>
-          <a:noFill/>
-        </p:spPr>
-        <p:txBody>
-          <a:bodyPr wrap="none" anchor="ctr">
-            <a:spAutoFit/>
-          </a:bodyPr>
-          <a:lstStyle/>
-          <a:p>
-            <a:pPr>
-              <a:defRPr sz="2000" b="1">
-                <a:solidFill>
-                  <a:srgbClr val="FFFFFF"/>
-                </a:solidFill>
-              </a:defRPr>
-            </a:pPr>
-            <a:r>
-              <a:t>Platform</a:t>
-            </a:r>
-          </a:p>
-        </p:txBody>
-      </p:sp>
-      <p:sp>
-        <p:nvSpPr>
-          <p:cNvPr id="18" name="TextBox 17"/>
-          <p:cNvSpPr txBox="1"/>
-          <p:nvPr/>
-        </p:nvSpPr>
-        <p:spPr>
-          <a:xfrm>
-            <a:off x="4585447" y="5671377"/>
-            <a:ext cx="4658648" cy="307777"/>
-          </a:xfrm>
-          <a:prstGeom prst="rect">
-            <a:avLst/>
-          </a:prstGeom>
-          <a:noFill/>
-        </p:spPr>
-        <p:txBody>
-          <a:bodyPr wrap="none" anchor="ctr">
-            <a:spAutoFit/>
-          </a:bodyPr>
-          <a:lstStyle/>
-          <a:p>
-            <a:pPr>
-              <a:defRPr sz="1400">
-                <a:solidFill>
-                  <a:srgbClr val="FFFFFF"/>
-                </a:solidFill>
-              </a:defRPr>
-            </a:pPr>
-            <a:r>
-              <a:rPr dirty="0"/>
-              <a:t>OpenShift 4.</a:t>
-            </a:r>
-            <a:r>
-              <a:rPr lang="en-US" dirty="0"/>
-              <a:t>20</a:t>
-            </a:r>
-            <a:r>
-              <a:rPr dirty="0"/>
-              <a:t>  ·  </a:t>
-            </a:r>
-            <a:r>
-              <a:rPr lang="en-US" dirty="0"/>
-              <a:t>OpenShift AI 3.5</a:t>
-            </a:r>
-            <a:r>
-              <a:rPr dirty="0"/>
-              <a:t>  ·  GPU Nodes (NVIDIA L40)</a:t>
-            </a:r>
-          </a:p>
-        </p:txBody>
-      </p:sp>
+        </p:spPr>
+      </p:pic>
     </p:spTree>
   </p:cSld>
   <p:clrMapOvr>
@@ -7049,8 +6443,8 @@
         </p:nvSpPr>
         <p:spPr>
           <a:xfrm>
-            <a:off x="0" y="-1"/>
-            <a:ext cx="12188825" cy="618565"/>
+            <a:off x="0" y="0"/>
+            <a:ext cx="12188825" cy="640080"/>
           </a:xfrm>
           <a:prstGeom prst="rect">
             <a:avLst/>
@@ -7093,8 +6487,8 @@
         </p:nvSpPr>
         <p:spPr>
           <a:xfrm>
-            <a:off x="2895393" y="45720"/>
-            <a:ext cx="6096413" cy="523220"/>
+            <a:off x="4365764" y="45720"/>
+            <a:ext cx="3155672" cy="523220"/>
           </a:xfrm>
           <a:prstGeom prst="rect">
             <a:avLst/>
@@ -7116,31 +6510,31 @@
             </a:pPr>
             <a:r>
               <a:rPr dirty="0"/>
-              <a:t>Infrastructure &amp; Resource Management</a:t>
-            </a:r>
-          </a:p>
-        </p:txBody>
-      </p:sp>
-      <p:sp>
-        <p:nvSpPr>
-          <p:cNvPr id="4" name="Rounded Rectangle 3"/>
+              <a:t>AI Application Stack</a:t>
+            </a:r>
+          </a:p>
+        </p:txBody>
+      </p:sp>
+      <p:sp>
+        <p:nvSpPr>
+          <p:cNvPr id="4" name="Rectangle 3"/>
           <p:cNvSpPr/>
           <p:nvPr/>
         </p:nvSpPr>
         <p:spPr>
           <a:xfrm>
-            <a:off x="914400" y="1828800"/>
-            <a:ext cx="5029200" cy="4114800"/>
-          </a:xfrm>
-          <a:prstGeom prst="roundRect">
+            <a:off x="335869" y="1058966"/>
+            <a:ext cx="5390017" cy="731520"/>
+          </a:xfrm>
+          <a:prstGeom prst="rect">
             <a:avLst/>
           </a:prstGeom>
           <a:solidFill>
-            <a:srgbClr val="E6F0FF"/>
+            <a:srgbClr val="C85050"/>
           </a:solidFill>
-          <a:ln w="25400">
+          <a:ln>
             <a:solidFill>
-              <a:srgbClr val="0066CC"/>
+              <a:srgbClr val="5C5C5C"/>
             </a:solidFill>
           </a:ln>
         </p:spPr>
@@ -7175,8 +6569,8 @@
         </p:nvSpPr>
         <p:spPr>
           <a:xfrm>
-            <a:off x="1188720" y="2011680"/>
-            <a:ext cx="4572000" cy="457200"/>
+            <a:off x="335869" y="1240060"/>
+            <a:ext cx="5390017" cy="369332"/>
           </a:xfrm>
           <a:prstGeom prst="rect">
             <a:avLst/>
@@ -7184,208 +6578,44 @@
           <a:noFill/>
         </p:spPr>
         <p:txBody>
-          <a:bodyPr wrap="none">
+          <a:bodyPr wrap="square" anchor="ctr">
             <a:spAutoFit/>
           </a:bodyPr>
           <a:lstStyle/>
           <a:p>
-            <a:pPr>
-              <a:defRPr sz="2200" b="1">
-                <a:solidFill>
-                  <a:srgbClr val="0066CC"/>
+            <a:pPr algn="ctr">
+              <a:defRPr sz="1800" b="1">
+                <a:solidFill>
+                  <a:srgbClr val="FFFFFF"/>
                 </a:solidFill>
               </a:defRPr>
             </a:pPr>
             <a:r>
-              <a:t>OpenShift Container Platform</a:t>
-            </a:r>
-          </a:p>
-        </p:txBody>
-      </p:sp>
-      <p:sp>
-        <p:nvSpPr>
-          <p:cNvPr id="6" name="TextBox 5"/>
-          <p:cNvSpPr txBox="1"/>
-          <p:nvPr/>
-        </p:nvSpPr>
-        <p:spPr>
-          <a:xfrm>
-            <a:off x="1371600" y="2743200"/>
-            <a:ext cx="4572000" cy="1954381"/>
+              <a:t>React SPA · AI Playground</a:t>
+            </a:r>
+          </a:p>
+        </p:txBody>
+      </p:sp>
+      <p:sp>
+        <p:nvSpPr>
+          <p:cNvPr id="6" name="Rectangle 5"/>
+          <p:cNvSpPr/>
+          <p:nvPr/>
+        </p:nvSpPr>
+        <p:spPr>
+          <a:xfrm>
+            <a:off x="335869" y="2146721"/>
+            <a:ext cx="5390017" cy="731520"/>
           </a:xfrm>
           <a:prstGeom prst="rect">
             <a:avLst/>
           </a:prstGeom>
-          <a:noFill/>
-        </p:spPr>
-        <p:txBody>
-          <a:bodyPr wrap="square">
-            <a:spAutoFit/>
-          </a:bodyPr>
-          <a:lstStyle/>
-          <a:p>
-            <a:pPr>
-              <a:spcAft>
-                <a:spcPts val="600"/>
-              </a:spcAft>
-              <a:defRPr sz="1400">
-                <a:solidFill>
-                  <a:srgbClr val="000000"/>
-                </a:solidFill>
-              </a:defRPr>
-            </a:pPr>
-            <a:r>
-              <a:rPr sz="1600" dirty="0"/>
-              <a:t>✓ Namespace Isolation (iso-platform, </a:t>
-            </a:r>
-            <a:r>
-              <a:rPr sz="1600" dirty="0" err="1"/>
-              <a:t>llm</a:t>
-            </a:r>
-            <a:r>
-              <a:rPr sz="1600" dirty="0"/>
-              <a:t>, </a:t>
-            </a:r>
-            <a:r>
-              <a:rPr sz="1600" dirty="0" err="1"/>
-              <a:t>grafana</a:t>
-            </a:r>
-            <a:r>
-              <a:rPr sz="1600" dirty="0"/>
-              <a:t>)</a:t>
-            </a:r>
-          </a:p>
-          <a:p>
-            <a:pPr>
-              <a:spcAft>
-                <a:spcPts val="600"/>
-              </a:spcAft>
-              <a:defRPr sz="1400">
-                <a:solidFill>
-                  <a:srgbClr val="000000"/>
-                </a:solidFill>
-              </a:defRPr>
-            </a:pPr>
-            <a:r>
-              <a:rPr sz="1600" dirty="0"/>
-              <a:t>✓ RBAC &amp; </a:t>
-            </a:r>
-            <a:r>
-              <a:rPr sz="1600" dirty="0" err="1"/>
-              <a:t>ServiceAccounts</a:t>
-            </a:r>
-            <a:endParaRPr sz="1600" dirty="0"/>
-          </a:p>
-          <a:p>
-            <a:pPr>
-              <a:spcAft>
-                <a:spcPts val="600"/>
-              </a:spcAft>
-              <a:defRPr sz="1400">
-                <a:solidFill>
-                  <a:srgbClr val="000000"/>
-                </a:solidFill>
-              </a:defRPr>
-            </a:pPr>
-            <a:r>
-              <a:rPr sz="1600" dirty="0"/>
-              <a:t>✓ Routes (TLS edge termination)</a:t>
-            </a:r>
-          </a:p>
-          <a:p>
-            <a:pPr>
-              <a:spcAft>
-                <a:spcPts val="600"/>
-              </a:spcAft>
-              <a:defRPr sz="1400">
-                <a:solidFill>
-                  <a:srgbClr val="000000"/>
-                </a:solidFill>
-              </a:defRPr>
-            </a:pPr>
-            <a:r>
-              <a:rPr sz="1600" dirty="0"/>
-              <a:t>✓ GPU Node Scheduling (L40 48GB VRAM)</a:t>
-            </a:r>
-          </a:p>
-          <a:p>
-            <a:pPr>
-              <a:spcAft>
-                <a:spcPts val="600"/>
-              </a:spcAft>
-              <a:defRPr sz="1400">
-                <a:solidFill>
-                  <a:srgbClr val="000000"/>
-                </a:solidFill>
-              </a:defRPr>
-            </a:pPr>
-            <a:r>
-              <a:rPr sz="1600" dirty="0"/>
-              <a:t>✓ </a:t>
-            </a:r>
-            <a:r>
-              <a:rPr sz="1600" dirty="0" err="1"/>
-              <a:t>StatefulSets</a:t>
-            </a:r>
-            <a:r>
-              <a:rPr sz="1600" dirty="0"/>
-              <a:t> (PostgreSQL + </a:t>
-            </a:r>
-            <a:r>
-              <a:rPr sz="1600" dirty="0" err="1"/>
-              <a:t>pgvector</a:t>
-            </a:r>
-            <a:r>
-              <a:rPr sz="1600" dirty="0"/>
-              <a:t>)</a:t>
-            </a:r>
-          </a:p>
-          <a:p>
-            <a:pPr>
-              <a:spcAft>
-                <a:spcPts val="600"/>
-              </a:spcAft>
-              <a:defRPr sz="1400">
-                <a:solidFill>
-                  <a:srgbClr val="000000"/>
-                </a:solidFill>
-              </a:defRPr>
-            </a:pPr>
-            <a:r>
-              <a:rPr sz="1600" dirty="0"/>
-              <a:t>✓ </a:t>
-            </a:r>
-            <a:r>
-              <a:rPr sz="1600" dirty="0" err="1"/>
-              <a:t>ConfigMaps</a:t>
-            </a:r>
-            <a:r>
-              <a:rPr sz="1600" dirty="0"/>
-              <a:t> &amp; Secrets Management</a:t>
-            </a:r>
-          </a:p>
-        </p:txBody>
-      </p:sp>
-      <p:sp>
-        <p:nvSpPr>
-          <p:cNvPr id="7" name="Rounded Rectangle 6"/>
-          <p:cNvSpPr/>
-          <p:nvPr/>
-        </p:nvSpPr>
-        <p:spPr>
-          <a:xfrm>
-            <a:off x="6400800" y="1828800"/>
-            <a:ext cx="5029200" cy="4114800"/>
-          </a:xfrm>
-          <a:prstGeom prst="roundRect">
-            <a:avLst/>
-          </a:prstGeom>
           <a:solidFill>
-            <a:srgbClr val="FFF0F0"/>
+            <a:srgbClr val="50A064"/>
           </a:solidFill>
-          <a:ln w="25400">
+          <a:ln>
             <a:solidFill>
-              <a:srgbClr val="EE0000"/>
+              <a:srgbClr val="5C5C5C"/>
             </a:solidFill>
           </a:ln>
         </p:spPr>
@@ -7414,14 +6644,14 @@
       </p:sp>
       <p:sp>
         <p:nvSpPr>
-          <p:cNvPr id="8" name="TextBox 7"/>
+          <p:cNvPr id="7" name="TextBox 6"/>
           <p:cNvSpPr txBox="1"/>
           <p:nvPr/>
         </p:nvSpPr>
         <p:spPr>
           <a:xfrm>
-            <a:off x="6675120" y="2011680"/>
-            <a:ext cx="4572000" cy="457200"/>
+            <a:off x="335869" y="2327815"/>
+            <a:ext cx="5390017" cy="369332"/>
           </a:xfrm>
           <a:prstGeom prst="rect">
             <a:avLst/>
@@ -7429,21 +6659,77 @@
           <a:noFill/>
         </p:spPr>
         <p:txBody>
-          <a:bodyPr wrap="none">
+          <a:bodyPr wrap="square" anchor="ctr">
             <a:spAutoFit/>
           </a:bodyPr>
           <a:lstStyle/>
           <a:p>
-            <a:pPr>
-              <a:defRPr sz="2200" b="1">
-                <a:solidFill>
-                  <a:srgbClr val="EE0000"/>
+            <a:pPr algn="ctr">
+              <a:defRPr sz="1800" b="1">
+                <a:solidFill>
+                  <a:srgbClr val="FFFFFF"/>
                 </a:solidFill>
               </a:defRPr>
             </a:pPr>
             <a:r>
-              <a:t>Red Hat OpenShift AI Operator</a:t>
-            </a:r>
+              <a:rPr dirty="0" err="1"/>
+              <a:t>FastAPI</a:t>
+            </a:r>
+            <a:r>
+              <a:rPr dirty="0"/>
+              <a:t> Orchestrator · Document </a:t>
+            </a:r>
+            <a:r>
+              <a:rPr lang="en-US" dirty="0"/>
+              <a:t>Agents</a:t>
+            </a:r>
+            <a:endParaRPr dirty="0"/>
+          </a:p>
+        </p:txBody>
+      </p:sp>
+      <p:sp>
+        <p:nvSpPr>
+          <p:cNvPr id="8" name="Rectangle 7"/>
+          <p:cNvSpPr/>
+          <p:nvPr/>
+        </p:nvSpPr>
+        <p:spPr>
+          <a:xfrm>
+            <a:off x="335869" y="4309114"/>
+            <a:ext cx="5390017" cy="731520"/>
+          </a:xfrm>
+          <a:prstGeom prst="rect">
+            <a:avLst/>
+          </a:prstGeom>
+          <a:solidFill>
+            <a:srgbClr val="A050C8"/>
+          </a:solidFill>
+          <a:ln>
+            <a:solidFill>
+              <a:srgbClr val="5C5C5C"/>
+            </a:solidFill>
+          </a:ln>
+        </p:spPr>
+        <p:style>
+          <a:lnRef idx="1">
+            <a:schemeClr val="accent1"/>
+          </a:lnRef>
+          <a:fillRef idx="3">
+            <a:schemeClr val="accent1"/>
+          </a:fillRef>
+          <a:effectRef idx="2">
+            <a:schemeClr val="accent1"/>
+          </a:effectRef>
+          <a:fontRef idx="minor">
+            <a:schemeClr val="lt1"/>
+          </a:fontRef>
+        </p:style>
+        <p:txBody>
+          <a:bodyPr rtlCol="0" anchor="ctr"/>
+          <a:lstStyle/>
+          <a:p>
+            <a:pPr algn="ctr"/>
+            <a:endParaRPr/>
           </a:p>
         </p:txBody>
       </p:sp>
@@ -7455,8 +6741,8 @@
         </p:nvSpPr>
         <p:spPr>
           <a:xfrm>
-            <a:off x="6858000" y="2743200"/>
-            <a:ext cx="3818965" cy="1954381"/>
+            <a:off x="335869" y="4490208"/>
+            <a:ext cx="5390017" cy="369332"/>
           </a:xfrm>
           <a:prstGeom prst="rect">
             <a:avLst/>
@@ -7464,172 +6750,226 @@
           <a:noFill/>
         </p:spPr>
         <p:txBody>
-          <a:bodyPr wrap="square">
+          <a:bodyPr wrap="square" anchor="ctr">
             <a:spAutoFit/>
           </a:bodyPr>
           <a:lstStyle/>
           <a:p>
-            <a:pPr>
-              <a:spcAft>
-                <a:spcPts val="600"/>
-              </a:spcAft>
-              <a:defRPr sz="1400">
-                <a:solidFill>
-                  <a:srgbClr val="000000"/>
+            <a:pPr algn="ctr">
+              <a:defRPr sz="1800" b="1">
+                <a:solidFill>
+                  <a:srgbClr val="FFFFFF"/>
                 </a:solidFill>
               </a:defRPr>
             </a:pPr>
             <a:r>
-              <a:rPr sz="1600" dirty="0"/>
-              <a:t>✓ Model Serving (</a:t>
-            </a:r>
-            <a:r>
-              <a:rPr sz="1600" dirty="0" err="1"/>
-              <a:t>KServe</a:t>
-            </a:r>
-            <a:r>
-              <a:rPr sz="1600" dirty="0"/>
-              <a:t>, </a:t>
-            </a:r>
-            <a:r>
-              <a:rPr sz="1600" dirty="0" err="1"/>
-              <a:t>vLLM</a:t>
-            </a:r>
-            <a:r>
-              <a:rPr sz="1600" dirty="0"/>
-              <a:t>)</a:t>
-            </a:r>
-          </a:p>
-          <a:p>
-            <a:pPr>
-              <a:spcAft>
-                <a:spcPts val="600"/>
-              </a:spcAft>
-              <a:defRPr sz="1400">
-                <a:solidFill>
-                  <a:srgbClr val="000000"/>
+              <a:t>LLM Models (GPT-oss-20b · BGE-M3 · Qwen3)</a:t>
+            </a:r>
+          </a:p>
+        </p:txBody>
+      </p:sp>
+      <p:sp>
+        <p:nvSpPr>
+          <p:cNvPr id="10" name="Rectangle 9"/>
+          <p:cNvSpPr/>
+          <p:nvPr/>
+        </p:nvSpPr>
+        <p:spPr>
+          <a:xfrm>
+            <a:off x="335869" y="3234476"/>
+            <a:ext cx="5390017" cy="731520"/>
+          </a:xfrm>
+          <a:prstGeom prst="rect">
+            <a:avLst/>
+          </a:prstGeom>
+          <a:solidFill>
+            <a:srgbClr val="3C78B4"/>
+          </a:solidFill>
+          <a:ln>
+            <a:solidFill>
+              <a:srgbClr val="5C5C5C"/>
+            </a:solidFill>
+          </a:ln>
+        </p:spPr>
+        <p:style>
+          <a:lnRef idx="1">
+            <a:schemeClr val="accent1"/>
+          </a:lnRef>
+          <a:fillRef idx="3">
+            <a:schemeClr val="accent1"/>
+          </a:fillRef>
+          <a:effectRef idx="2">
+            <a:schemeClr val="accent1"/>
+          </a:effectRef>
+          <a:fontRef idx="minor">
+            <a:schemeClr val="lt1"/>
+          </a:fontRef>
+        </p:style>
+        <p:txBody>
+          <a:bodyPr rtlCol="0" anchor="ctr"/>
+          <a:lstStyle/>
+          <a:p>
+            <a:pPr algn="ctr"/>
+            <a:endParaRPr/>
+          </a:p>
+        </p:txBody>
+      </p:sp>
+      <p:sp>
+        <p:nvSpPr>
+          <p:cNvPr id="11" name="TextBox 10"/>
+          <p:cNvSpPr txBox="1"/>
+          <p:nvPr/>
+        </p:nvSpPr>
+        <p:spPr>
+          <a:xfrm>
+            <a:off x="335869" y="3415570"/>
+            <a:ext cx="5390017" cy="369332"/>
+          </a:xfrm>
+          <a:prstGeom prst="rect">
+            <a:avLst/>
+          </a:prstGeom>
+          <a:noFill/>
+        </p:spPr>
+        <p:txBody>
+          <a:bodyPr wrap="square" anchor="ctr">
+            <a:spAutoFit/>
+          </a:bodyPr>
+          <a:lstStyle/>
+          <a:p>
+            <a:pPr algn="ctr">
+              <a:defRPr sz="1800" b="1">
+                <a:solidFill>
+                  <a:srgbClr val="FFFFFF"/>
                 </a:solidFill>
               </a:defRPr>
             </a:pPr>
             <a:r>
-              <a:rPr sz="1600" dirty="0"/>
-              <a:t>✓ </a:t>
-            </a:r>
-            <a:r>
-              <a:rPr sz="1600" dirty="0" err="1"/>
-              <a:t>MaaS</a:t>
-            </a:r>
-            <a:r>
-              <a:rPr sz="1600" dirty="0"/>
-              <a:t> Gateway (</a:t>
-            </a:r>
-            <a:r>
-              <a:rPr sz="1600" dirty="0" err="1"/>
-              <a:t>Kuadrant</a:t>
-            </a:r>
-            <a:r>
-              <a:rPr sz="1600" dirty="0"/>
-              <a:t> API </a:t>
-            </a:r>
-            <a:r>
-              <a:rPr sz="1600" dirty="0" err="1"/>
-              <a:t>mgmt</a:t>
-            </a:r>
-            <a:r>
-              <a:rPr sz="1600" dirty="0"/>
-              <a:t>)</a:t>
-            </a:r>
-          </a:p>
-          <a:p>
-            <a:pPr>
-              <a:spcAft>
-                <a:spcPts val="600"/>
-              </a:spcAft>
-              <a:defRPr sz="1400">
-                <a:solidFill>
-                  <a:srgbClr val="000000"/>
+              <a:rPr dirty="0"/>
+              <a:t>PostgreSQL 16 + </a:t>
+            </a:r>
+            <a:r>
+              <a:rPr dirty="0" err="1"/>
+              <a:t>pgvector</a:t>
+            </a:r>
+            <a:r>
+              <a:rPr dirty="0"/>
+              <a:t> · Redis</a:t>
+            </a:r>
+          </a:p>
+        </p:txBody>
+      </p:sp>
+      <p:sp>
+        <p:nvSpPr>
+          <p:cNvPr id="12" name="Rectangle 11"/>
+          <p:cNvSpPr/>
+          <p:nvPr/>
+        </p:nvSpPr>
+        <p:spPr>
+          <a:xfrm>
+            <a:off x="335869" y="5357539"/>
+            <a:ext cx="5390017" cy="731520"/>
+          </a:xfrm>
+          <a:prstGeom prst="rect">
+            <a:avLst/>
+          </a:prstGeom>
+          <a:solidFill>
+            <a:srgbClr val="646464"/>
+          </a:solidFill>
+          <a:ln>
+            <a:solidFill>
+              <a:srgbClr val="5C5C5C"/>
+            </a:solidFill>
+          </a:ln>
+        </p:spPr>
+        <p:style>
+          <a:lnRef idx="1">
+            <a:schemeClr val="accent1"/>
+          </a:lnRef>
+          <a:fillRef idx="3">
+            <a:schemeClr val="accent1"/>
+          </a:fillRef>
+          <a:effectRef idx="2">
+            <a:schemeClr val="accent1"/>
+          </a:effectRef>
+          <a:fontRef idx="minor">
+            <a:schemeClr val="lt1"/>
+          </a:fontRef>
+        </p:style>
+        <p:txBody>
+          <a:bodyPr rtlCol="0" anchor="ctr"/>
+          <a:lstStyle/>
+          <a:p>
+            <a:pPr algn="ctr"/>
+            <a:endParaRPr/>
+          </a:p>
+        </p:txBody>
+      </p:sp>
+      <p:sp>
+        <p:nvSpPr>
+          <p:cNvPr id="13" name="TextBox 12"/>
+          <p:cNvSpPr txBox="1"/>
+          <p:nvPr/>
+        </p:nvSpPr>
+        <p:spPr>
+          <a:xfrm>
+            <a:off x="335869" y="5538633"/>
+            <a:ext cx="5390017" cy="369332"/>
+          </a:xfrm>
+          <a:prstGeom prst="rect">
+            <a:avLst/>
+          </a:prstGeom>
+          <a:noFill/>
+        </p:spPr>
+        <p:txBody>
+          <a:bodyPr wrap="square" anchor="ctr">
+            <a:spAutoFit/>
+          </a:bodyPr>
+          <a:lstStyle/>
+          <a:p>
+            <a:pPr algn="ctr">
+              <a:defRPr sz="1800" b="1">
+                <a:solidFill>
+                  <a:srgbClr val="FFFFFF"/>
                 </a:solidFill>
               </a:defRPr>
             </a:pPr>
             <a:r>
-              <a:rPr sz="1600" dirty="0"/>
-              <a:t>✓ </a:t>
-            </a:r>
-            <a:r>
-              <a:rPr sz="1600" dirty="0" err="1"/>
-              <a:t>TrustyAI</a:t>
-            </a:r>
-            <a:r>
-              <a:rPr sz="1600" dirty="0"/>
-              <a:t> Service (Observability)</a:t>
-            </a:r>
-          </a:p>
-          <a:p>
-            <a:pPr>
-              <a:spcAft>
-                <a:spcPts val="600"/>
-              </a:spcAft>
-              <a:defRPr sz="1400">
-                <a:solidFill>
-                  <a:srgbClr val="000000"/>
-                </a:solidFill>
-              </a:defRPr>
-            </a:pPr>
-            <a:r>
-              <a:rPr sz="1600" dirty="0"/>
-              <a:t>✓ Ray Operator (Distributed ML)</a:t>
-            </a:r>
-          </a:p>
-          <a:p>
-            <a:pPr>
-              <a:spcAft>
-                <a:spcPts val="600"/>
-              </a:spcAft>
-              <a:defRPr sz="1400">
-                <a:solidFill>
-                  <a:srgbClr val="000000"/>
-                </a:solidFill>
-              </a:defRPr>
-            </a:pPr>
-            <a:r>
-              <a:rPr sz="1600" dirty="0"/>
-              <a:t>✓ </a:t>
-            </a:r>
-            <a:r>
-              <a:rPr sz="1600" dirty="0" err="1"/>
-              <a:t>MLflow</a:t>
-            </a:r>
-            <a:r>
-              <a:rPr sz="1600" dirty="0"/>
-              <a:t> (Experiment Tracking)</a:t>
-            </a:r>
-          </a:p>
-          <a:p>
-            <a:pPr>
-              <a:spcAft>
-                <a:spcPts val="600"/>
-              </a:spcAft>
-              <a:defRPr sz="1400">
-                <a:solidFill>
-                  <a:srgbClr val="000000"/>
-                </a:solidFill>
-              </a:defRPr>
-            </a:pPr>
-            <a:r>
-              <a:rPr sz="1600" dirty="0"/>
-              <a:t>✓ Data Science Pipelines (</a:t>
-            </a:r>
-            <a:r>
-              <a:rPr sz="1600" dirty="0" err="1"/>
-              <a:t>Tekton</a:t>
-            </a:r>
-            <a:r>
-              <a:rPr sz="1600" dirty="0"/>
-              <a:t>)</a:t>
-            </a:r>
-          </a:p>
-        </p:txBody>
-      </p:sp>
+              <a:rPr dirty="0"/>
+              <a:t>OpenShift + RHOAI</a:t>
+            </a:r>
+          </a:p>
+        </p:txBody>
+      </p:sp>
+      <p:pic>
+        <p:nvPicPr>
+          <p:cNvPr id="15" name="Picture 14">
+            <a:extLst>
+              <a:ext uri="{FF2B5EF4-FFF2-40B4-BE49-F238E27FC236}">
+                <a16:creationId xmlns:a16="http://schemas.microsoft.com/office/drawing/2014/main" id="{513149F8-E052-25C7-414A-FAE1FD8059BA}"/>
+              </a:ext>
+            </a:extLst>
+          </p:cNvPr>
+          <p:cNvPicPr>
+            <a:picLocks noChangeAspect="1"/>
+          </p:cNvPicPr>
+          <p:nvPr/>
+        </p:nvPicPr>
+        <p:blipFill>
+          <a:blip r:embed="rId2"/>
+          <a:stretch>
+            <a:fillRect/>
+          </a:stretch>
+        </p:blipFill>
+        <p:spPr>
+          <a:xfrm>
+            <a:off x="5943600" y="1150497"/>
+            <a:ext cx="5720178" cy="4757468"/>
+          </a:xfrm>
+          <a:prstGeom prst="rect">
+            <a:avLst/>
+          </a:prstGeom>
+        </p:spPr>
+      </p:pic>
     </p:spTree>
   </p:cSld>
   <p:clrMapOvr>
@@ -7664,7 +7004,7 @@
         <p:spPr>
           <a:xfrm>
             <a:off x="0" y="0"/>
-            <a:ext cx="12188825" cy="640080"/>
+            <a:ext cx="12188825" cy="666974"/>
           </a:xfrm>
           <a:prstGeom prst="rect">
             <a:avLst/>
@@ -7707,8 +7047,8 @@
         </p:nvSpPr>
         <p:spPr>
           <a:xfrm>
-            <a:off x="4365764" y="45720"/>
-            <a:ext cx="3155672" cy="523220"/>
+            <a:off x="457199" y="45720"/>
+            <a:ext cx="11310258" cy="523220"/>
           </a:xfrm>
           <a:prstGeom prst="rect">
             <a:avLst/>
@@ -7716,7 +7056,7 @@
           <a:noFill/>
         </p:spPr>
         <p:txBody>
-          <a:bodyPr wrap="none">
+          <a:bodyPr wrap="square">
             <a:spAutoFit/>
           </a:bodyPr>
           <a:lstStyle/>
@@ -7730,8 +7070,13 @@
             </a:pPr>
             <a:r>
               <a:rPr dirty="0"/>
-              <a:t>AI Application Stack</a:t>
-            </a:r>
+              <a:t>Architecture</a:t>
+            </a:r>
+            <a:r>
+              <a:rPr lang="en-US" dirty="0"/>
+              <a:t> layers</a:t>
+            </a:r>
+            <a:endParaRPr dirty="0"/>
           </a:p>
         </p:txBody>
       </p:sp>
@@ -7743,18 +7088,18 @@
         </p:nvSpPr>
         <p:spPr>
           <a:xfrm>
-            <a:off x="335869" y="1058966"/>
-            <a:ext cx="5390017" cy="731520"/>
+            <a:off x="1385047" y="1344706"/>
+            <a:ext cx="9144000" cy="731520"/>
           </a:xfrm>
           <a:prstGeom prst="rect">
             <a:avLst/>
           </a:prstGeom>
           <a:solidFill>
-            <a:srgbClr val="C85050"/>
+            <a:srgbClr val="0066CC"/>
           </a:solidFill>
           <a:ln>
             <a:solidFill>
-              <a:srgbClr val="5C5C5C"/>
+              <a:srgbClr val="0066CC"/>
             </a:solidFill>
           </a:ln>
         </p:spPr>
@@ -7789,8 +7134,8 @@
         </p:nvSpPr>
         <p:spPr>
           <a:xfrm>
-            <a:off x="335869" y="1240060"/>
-            <a:ext cx="5390017" cy="369332"/>
+            <a:off x="1567927" y="1436146"/>
+            <a:ext cx="2743200" cy="548640"/>
           </a:xfrm>
           <a:prstGeom prst="rect">
             <a:avLst/>
@@ -7798,44 +7143,93 @@
           <a:noFill/>
         </p:spPr>
         <p:txBody>
-          <a:bodyPr wrap="square" anchor="ctr">
+          <a:bodyPr wrap="none" anchor="ctr">
             <a:spAutoFit/>
           </a:bodyPr>
           <a:lstStyle/>
           <a:p>
-            <a:pPr algn="ctr">
-              <a:defRPr sz="1800" b="1">
+            <a:pPr>
+              <a:defRPr sz="2000" b="1">
                 <a:solidFill>
                   <a:srgbClr val="FFFFFF"/>
                 </a:solidFill>
               </a:defRPr>
             </a:pPr>
             <a:r>
-              <a:t>React SPA · AI Playground</a:t>
-            </a:r>
-          </a:p>
-        </p:txBody>
-      </p:sp>
-      <p:sp>
-        <p:nvSpPr>
-          <p:cNvPr id="6" name="Rectangle 5"/>
+              <a:t>Application Layer</a:t>
+            </a:r>
+          </a:p>
+        </p:txBody>
+      </p:sp>
+      <p:sp>
+        <p:nvSpPr>
+          <p:cNvPr id="6" name="TextBox 5"/>
+          <p:cNvSpPr txBox="1"/>
+          <p:nvPr/>
+        </p:nvSpPr>
+        <p:spPr>
+          <a:xfrm>
+            <a:off x="4585447" y="1556577"/>
+            <a:ext cx="4143635" cy="307777"/>
+          </a:xfrm>
+          <a:prstGeom prst="rect">
+            <a:avLst/>
+          </a:prstGeom>
+          <a:noFill/>
+        </p:spPr>
+        <p:txBody>
+          <a:bodyPr wrap="none" anchor="ctr">
+            <a:spAutoFit/>
+          </a:bodyPr>
+          <a:lstStyle/>
+          <a:p>
+            <a:pPr>
+              <a:defRPr sz="1400">
+                <a:solidFill>
+                  <a:srgbClr val="FFFFFF"/>
+                </a:solidFill>
+              </a:defRPr>
+            </a:pPr>
+            <a:r>
+              <a:rPr dirty="0"/>
+              <a:t>iso-web  ·  iso-</a:t>
+            </a:r>
+            <a:r>
+              <a:rPr dirty="0" err="1"/>
+              <a:t>api</a:t>
+            </a:r>
+            <a:r>
+              <a:rPr dirty="0"/>
+              <a:t>  ·  AI Playground</a:t>
+            </a:r>
+            <a:r>
+              <a:rPr lang="en-IL" dirty="0"/>
+              <a:t> · functioonal agents</a:t>
+            </a:r>
+            <a:endParaRPr dirty="0"/>
+          </a:p>
+        </p:txBody>
+      </p:sp>
+      <p:sp>
+        <p:nvSpPr>
+          <p:cNvPr id="7" name="Rectangle 6"/>
           <p:cNvSpPr/>
           <p:nvPr/>
         </p:nvSpPr>
         <p:spPr>
           <a:xfrm>
-            <a:off x="335869" y="2146721"/>
-            <a:ext cx="5390017" cy="731520"/>
+            <a:off x="1385047" y="2460170"/>
+            <a:ext cx="9144000" cy="896215"/>
           </a:xfrm>
           <a:prstGeom prst="rect">
             <a:avLst/>
           </a:prstGeom>
           <a:solidFill>
-            <a:srgbClr val="50A064"/>
+            <a:srgbClr val="7030A0"/>
           </a:solidFill>
           <a:ln>
             <a:solidFill>
-              <a:srgbClr val="5C5C5C"/>
+              <a:srgbClr val="7030A0"/>
             </a:solidFill>
           </a:ln>
         </p:spPr>
@@ -7864,14 +7258,14 @@
       </p:sp>
       <p:sp>
         <p:nvSpPr>
-          <p:cNvPr id="7" name="TextBox 6"/>
+          <p:cNvPr id="8" name="TextBox 7"/>
           <p:cNvSpPr txBox="1"/>
           <p:nvPr/>
         </p:nvSpPr>
         <p:spPr>
           <a:xfrm>
-            <a:off x="335869" y="2327815"/>
-            <a:ext cx="5390017" cy="369332"/>
+            <a:off x="1567927" y="2350546"/>
+            <a:ext cx="2743200" cy="914400"/>
           </a:xfrm>
           <a:prstGeom prst="rect">
             <a:avLst/>
@@ -7879,54 +7273,88 @@
           <a:noFill/>
         </p:spPr>
         <p:txBody>
-          <a:bodyPr wrap="square" anchor="ctr">
+          <a:bodyPr wrap="none" anchor="ctr">
             <a:spAutoFit/>
           </a:bodyPr>
           <a:lstStyle/>
           <a:p>
-            <a:pPr algn="ctr">
-              <a:defRPr sz="1800" b="1">
+            <a:pPr>
+              <a:defRPr sz="2000" b="1">
                 <a:solidFill>
                   <a:srgbClr val="FFFFFF"/>
                 </a:solidFill>
               </a:defRPr>
             </a:pPr>
             <a:r>
+              <a:t>Model as a Service</a:t>
+            </a:r>
+          </a:p>
+        </p:txBody>
+      </p:sp>
+      <p:sp>
+        <p:nvSpPr>
+          <p:cNvPr id="9" name="TextBox 8"/>
+          <p:cNvSpPr txBox="1"/>
+          <p:nvPr/>
+        </p:nvSpPr>
+        <p:spPr>
+          <a:xfrm>
+            <a:off x="4585447" y="2350546"/>
+            <a:ext cx="5486400" cy="914400"/>
+          </a:xfrm>
+          <a:prstGeom prst="rect">
+            <a:avLst/>
+          </a:prstGeom>
+          <a:noFill/>
+        </p:spPr>
+        <p:txBody>
+          <a:bodyPr wrap="none" anchor="ctr">
+            <a:spAutoFit/>
+          </a:bodyPr>
+          <a:lstStyle/>
+          <a:p>
+            <a:pPr>
+              <a:defRPr sz="1400">
+                <a:solidFill>
+                  <a:srgbClr val="FFFFFF"/>
+                </a:solidFill>
+              </a:defRPr>
+            </a:pPr>
+            <a:r>
+              <a:rPr dirty="0"/>
+              <a:t>GPT-oss-20b (21B </a:t>
+            </a:r>
+            <a:r>
               <a:rPr dirty="0" err="1"/>
-              <a:t>FastAPI</a:t>
+              <a:t>MoE</a:t>
             </a:r>
             <a:r>
               <a:rPr dirty="0"/>
-              <a:t> Orchestrator · Document </a:t>
-            </a:r>
-            <a:r>
-              <a:rPr lang="en-US" dirty="0"/>
-              <a:t>Agents</a:t>
-            </a:r>
-            <a:endParaRPr dirty="0"/>
-          </a:p>
-        </p:txBody>
-      </p:sp>
-      <p:sp>
-        <p:nvSpPr>
-          <p:cNvPr id="8" name="Rectangle 7"/>
+              <a:t>)  ·  BGE-M3 Embeddings  ·  Qwen3-4B</a:t>
+            </a:r>
+          </a:p>
+        </p:txBody>
+      </p:sp>
+      <p:sp>
+        <p:nvSpPr>
+          <p:cNvPr id="10" name="Rectangle 9"/>
           <p:cNvSpPr/>
           <p:nvPr/>
         </p:nvSpPr>
         <p:spPr>
           <a:xfrm>
-            <a:off x="335869" y="4309114"/>
-            <a:ext cx="5390017" cy="731520"/>
+            <a:off x="1385047" y="4453666"/>
+            <a:ext cx="9144000" cy="731520"/>
           </a:xfrm>
           <a:prstGeom prst="rect">
             <a:avLst/>
           </a:prstGeom>
           <a:solidFill>
-            <a:srgbClr val="A050C8"/>
+            <a:srgbClr val="92D050"/>
           </a:solidFill>
           <a:ln>
             <a:solidFill>
-              <a:srgbClr val="5C5C5C"/>
+              <a:srgbClr val="92D050"/>
             </a:solidFill>
           </a:ln>
         </p:spPr>
@@ -7955,14 +7383,14 @@
       </p:sp>
       <p:sp>
         <p:nvSpPr>
-          <p:cNvPr id="9" name="TextBox 8"/>
+          <p:cNvPr id="11" name="TextBox 10"/>
           <p:cNvSpPr txBox="1"/>
           <p:nvPr/>
         </p:nvSpPr>
         <p:spPr>
           <a:xfrm>
-            <a:off x="335869" y="4490208"/>
-            <a:ext cx="5390017" cy="369332"/>
+            <a:off x="1567927" y="4545106"/>
+            <a:ext cx="2743200" cy="548640"/>
           </a:xfrm>
           <a:prstGeom prst="rect">
             <a:avLst/>
@@ -7970,44 +7398,97 @@
           <a:noFill/>
         </p:spPr>
         <p:txBody>
-          <a:bodyPr wrap="square" anchor="ctr">
+          <a:bodyPr wrap="none" anchor="ctr">
             <a:spAutoFit/>
           </a:bodyPr>
           <a:lstStyle/>
           <a:p>
-            <a:pPr algn="ctr">
-              <a:defRPr sz="1800" b="1">
+            <a:pPr>
+              <a:defRPr sz="2000" b="1">
                 <a:solidFill>
                   <a:srgbClr val="FFFFFF"/>
                 </a:solidFill>
               </a:defRPr>
             </a:pPr>
             <a:r>
-              <a:t>LLM Models (GPT-oss-20b · BGE-M3 · Qwen3)</a:t>
-            </a:r>
-          </a:p>
-        </p:txBody>
-      </p:sp>
-      <p:sp>
-        <p:nvSpPr>
-          <p:cNvPr id="10" name="Rectangle 9"/>
+              <a:t>Inference &amp; Serving</a:t>
+            </a:r>
+          </a:p>
+        </p:txBody>
+      </p:sp>
+      <p:sp>
+        <p:nvSpPr>
+          <p:cNvPr id="12" name="TextBox 11"/>
+          <p:cNvSpPr txBox="1"/>
+          <p:nvPr/>
+        </p:nvSpPr>
+        <p:spPr>
+          <a:xfrm>
+            <a:off x="4585447" y="4665537"/>
+            <a:ext cx="2994859" cy="307777"/>
+          </a:xfrm>
+          <a:prstGeom prst="rect">
+            <a:avLst/>
+          </a:prstGeom>
+          <a:noFill/>
+        </p:spPr>
+        <p:txBody>
+          <a:bodyPr wrap="none" anchor="ctr">
+            <a:spAutoFit/>
+          </a:bodyPr>
+          <a:lstStyle/>
+          <a:p>
+            <a:pPr>
+              <a:defRPr sz="1400">
+                <a:solidFill>
+                  <a:srgbClr val="FFFFFF"/>
+                </a:solidFill>
+              </a:defRPr>
+            </a:pPr>
+            <a:r>
+              <a:rPr dirty="0" err="1"/>
+              <a:t>KServe</a:t>
+            </a:r>
+            <a:r>
+              <a:rPr dirty="0"/>
+              <a:t>  ·  </a:t>
+            </a:r>
+            <a:r>
+              <a:rPr dirty="0" err="1"/>
+              <a:t>vLLM</a:t>
+            </a:r>
+            <a:r>
+              <a:rPr dirty="0"/>
+              <a:t>  ·  </a:t>
+            </a:r>
+            <a:r>
+              <a:rPr dirty="0" err="1"/>
+              <a:t>LLMInferenceService</a:t>
+            </a:r>
+            <a:endParaRPr dirty="0"/>
+          </a:p>
+        </p:txBody>
+      </p:sp>
+      <p:sp>
+        <p:nvSpPr>
+          <p:cNvPr id="13" name="Rectangle 12"/>
           <p:cNvSpPr/>
           <p:nvPr/>
         </p:nvSpPr>
         <p:spPr>
           <a:xfrm>
-            <a:off x="335869" y="3234476"/>
-            <a:ext cx="5390017" cy="731520"/>
+            <a:off x="1385047" y="3539266"/>
+            <a:ext cx="9144000" cy="731520"/>
           </a:xfrm>
           <a:prstGeom prst="rect">
             <a:avLst/>
           </a:prstGeom>
           <a:solidFill>
-            <a:srgbClr val="3C78B4"/>
+            <a:srgbClr val="FFC000"/>
           </a:solidFill>
           <a:ln>
             <a:solidFill>
-              <a:srgbClr val="5C5C5C"/>
+              <a:srgbClr val="FFC000"/>
             </a:solidFill>
           </a:ln>
         </p:spPr>
@@ -8036,14 +7517,14 @@
       </p:sp>
       <p:sp>
         <p:nvSpPr>
-          <p:cNvPr id="11" name="TextBox 10"/>
+          <p:cNvPr id="14" name="TextBox 13"/>
           <p:cNvSpPr txBox="1"/>
           <p:nvPr/>
         </p:nvSpPr>
         <p:spPr>
           <a:xfrm>
-            <a:off x="335869" y="3415570"/>
-            <a:ext cx="5390017" cy="369332"/>
+            <a:off x="1567927" y="3630706"/>
+            <a:ext cx="2743200" cy="548640"/>
           </a:xfrm>
           <a:prstGeom prst="rect">
             <a:avLst/>
@@ -8051,49 +7532,75 @@
           <a:noFill/>
         </p:spPr>
         <p:txBody>
-          <a:bodyPr wrap="square" anchor="ctr">
+          <a:bodyPr wrap="none" anchor="ctr">
             <a:spAutoFit/>
           </a:bodyPr>
           <a:lstStyle/>
           <a:p>
-            <a:pPr algn="ctr">
-              <a:defRPr sz="1800" b="1">
+            <a:pPr>
+              <a:defRPr sz="2000" b="1">
                 <a:solidFill>
                   <a:srgbClr val="FFFFFF"/>
                 </a:solidFill>
               </a:defRPr>
             </a:pPr>
             <a:r>
-              <a:rPr dirty="0"/>
-              <a:t>PostgreSQL 16 + </a:t>
-            </a:r>
-            <a:r>
-              <a:rPr dirty="0" err="1"/>
-              <a:t>pgvector</a:t>
-            </a:r>
-            <a:r>
-              <a:rPr dirty="0"/>
-              <a:t> · Redis</a:t>
-            </a:r>
-          </a:p>
-        </p:txBody>
-      </p:sp>
-      <p:sp>
-        <p:nvSpPr>
-          <p:cNvPr id="12" name="Rectangle 11"/>
+              <a:t>AI Governance</a:t>
+            </a:r>
+          </a:p>
+        </p:txBody>
+      </p:sp>
+      <p:sp>
+        <p:nvSpPr>
+          <p:cNvPr id="15" name="TextBox 14"/>
+          <p:cNvSpPr txBox="1"/>
+          <p:nvPr/>
+        </p:nvSpPr>
+        <p:spPr>
+          <a:xfrm>
+            <a:off x="4585447" y="3630706"/>
+            <a:ext cx="5486400" cy="548640"/>
+          </a:xfrm>
+          <a:prstGeom prst="rect">
+            <a:avLst/>
+          </a:prstGeom>
+          <a:noFill/>
+        </p:spPr>
+        <p:txBody>
+          <a:bodyPr wrap="none" anchor="ctr">
+            <a:spAutoFit/>
+          </a:bodyPr>
+          <a:lstStyle/>
+          <a:p>
+            <a:pPr>
+              <a:defRPr sz="1400">
+                <a:solidFill>
+                  <a:srgbClr val="FFFFFF"/>
+                </a:solidFill>
+              </a:defRPr>
+            </a:pPr>
+            <a:r>
+              <a:t>TrustyAI  ·  Guardrails Orchestrator  ·  Kuadrant + Authorino</a:t>
+            </a:r>
+          </a:p>
+        </p:txBody>
+      </p:sp>
+      <p:sp>
+        <p:nvSpPr>
+          <p:cNvPr id="16" name="Rectangle 15"/>
           <p:cNvSpPr/>
           <p:nvPr/>
         </p:nvSpPr>
         <p:spPr>
           <a:xfrm>
-            <a:off x="335869" y="5357539"/>
-            <a:ext cx="5390017" cy="731520"/>
+            <a:off x="1385047" y="5459506"/>
+            <a:ext cx="9144000" cy="731520"/>
           </a:xfrm>
           <a:prstGeom prst="rect">
             <a:avLst/>
           </a:prstGeom>
           <a:solidFill>
-            <a:srgbClr val="646464"/>
+            <a:srgbClr val="5C5C5C"/>
           </a:solidFill>
           <a:ln>
             <a:solidFill>
@@ -8126,14 +7633,14 @@
       </p:sp>
       <p:sp>
         <p:nvSpPr>
-          <p:cNvPr id="13" name="TextBox 12"/>
+          <p:cNvPr id="17" name="TextBox 16"/>
           <p:cNvSpPr txBox="1"/>
           <p:nvPr/>
         </p:nvSpPr>
         <p:spPr>
           <a:xfrm>
-            <a:off x="335869" y="5538633"/>
-            <a:ext cx="5390017" cy="369332"/>
+            <a:off x="1567927" y="5550946"/>
+            <a:ext cx="2743200" cy="548640"/>
           </a:xfrm>
           <a:prstGeom prst="rect">
             <a:avLst/>
@@ -8141,55 +7648,76 @@
           <a:noFill/>
         </p:spPr>
         <p:txBody>
-          <a:bodyPr wrap="square" anchor="ctr">
+          <a:bodyPr wrap="none" anchor="ctr">
             <a:spAutoFit/>
           </a:bodyPr>
           <a:lstStyle/>
           <a:p>
-            <a:pPr algn="ctr">
-              <a:defRPr sz="1800" b="1">
+            <a:pPr>
+              <a:defRPr sz="2000" b="1">
                 <a:solidFill>
                   <a:srgbClr val="FFFFFF"/>
                 </a:solidFill>
               </a:defRPr>
             </a:pPr>
             <a:r>
+              <a:t>Platform</a:t>
+            </a:r>
+          </a:p>
+        </p:txBody>
+      </p:sp>
+      <p:sp>
+        <p:nvSpPr>
+          <p:cNvPr id="18" name="TextBox 17"/>
+          <p:cNvSpPr txBox="1"/>
+          <p:nvPr/>
+        </p:nvSpPr>
+        <p:spPr>
+          <a:xfrm>
+            <a:off x="4585447" y="5671377"/>
+            <a:ext cx="4658648" cy="307777"/>
+          </a:xfrm>
+          <a:prstGeom prst="rect">
+            <a:avLst/>
+          </a:prstGeom>
+          <a:noFill/>
+        </p:spPr>
+        <p:txBody>
+          <a:bodyPr wrap="none" anchor="ctr">
+            <a:spAutoFit/>
+          </a:bodyPr>
+          <a:lstStyle/>
+          <a:p>
+            <a:pPr>
+              <a:defRPr sz="1400">
+                <a:solidFill>
+                  <a:srgbClr val="FFFFFF"/>
+                </a:solidFill>
+              </a:defRPr>
+            </a:pPr>
+            <a:r>
               <a:rPr dirty="0"/>
-              <a:t>OpenShift + RHOAI</a:t>
-            </a:r>
-          </a:p>
-        </p:txBody>
-      </p:sp>
-      <p:pic>
-        <p:nvPicPr>
-          <p:cNvPr id="15" name="Picture 14">
-            <a:extLst>
-              <a:ext uri="{FF2B5EF4-FFF2-40B4-BE49-F238E27FC236}">
-                <a16:creationId xmlns:a16="http://schemas.microsoft.com/office/drawing/2014/main" id="{513149F8-E052-25C7-414A-FAE1FD8059BA}"/>
-              </a:ext>
-            </a:extLst>
-          </p:cNvPr>
-          <p:cNvPicPr>
-            <a:picLocks noChangeAspect="1"/>
-          </p:cNvPicPr>
-          <p:nvPr/>
-        </p:nvPicPr>
-        <p:blipFill>
-          <a:blip r:embed="rId2"/>
-          <a:stretch>
-            <a:fillRect/>
-          </a:stretch>
-        </p:blipFill>
-        <p:spPr>
-          <a:xfrm>
-            <a:off x="5943600" y="1150497"/>
-            <a:ext cx="5720178" cy="4757468"/>
-          </a:xfrm>
-          <a:prstGeom prst="rect">
-            <a:avLst/>
-          </a:prstGeom>
-        </p:spPr>
-      </p:pic>
+              <a:t>OpenShift 4.</a:t>
+            </a:r>
+            <a:r>
+              <a:rPr lang="en-US" dirty="0"/>
+              <a:t>20</a:t>
+            </a:r>
+            <a:r>
+              <a:rPr dirty="0"/>
+              <a:t>  ·  </a:t>
+            </a:r>
+            <a:r>
+              <a:rPr lang="en-US" dirty="0"/>
+              <a:t>OpenShift AI 3.5</a:t>
+            </a:r>
+            <a:r>
+              <a:rPr dirty="0"/>
+              <a:t>  ·  GPU Nodes (NVIDIA L40)</a:t>
+            </a:r>
+          </a:p>
+        </p:txBody>
+      </p:sp>
     </p:spTree>
   </p:cSld>
   <p:clrMapOvr>
@@ -8199,6 +7727,620 @@
 </file>
 
 <file path=ppt/slides/slide6.xml><?xml version="1.0" encoding="utf-8"?>
+<p:sld xmlns:a="http://schemas.openxmlformats.org/drawingml/2006/main" xmlns:r="http://schemas.openxmlformats.org/officeDocument/2006/relationships" xmlns:p="http://schemas.openxmlformats.org/presentationml/2006/main">
+  <p:cSld>
+    <p:spTree>
+      <p:nvGrpSpPr>
+        <p:cNvPr id="1" name=""/>
+        <p:cNvGrpSpPr/>
+        <p:nvPr/>
+      </p:nvGrpSpPr>
+      <p:grpSpPr>
+        <a:xfrm>
+          <a:off x="0" y="0"/>
+          <a:ext cx="0" cy="0"/>
+          <a:chOff x="0" y="0"/>
+          <a:chExt cx="0" cy="0"/>
+        </a:xfrm>
+      </p:grpSpPr>
+      <p:sp>
+        <p:nvSpPr>
+          <p:cNvPr id="2" name="Rectangle 1"/>
+          <p:cNvSpPr/>
+          <p:nvPr/>
+        </p:nvSpPr>
+        <p:spPr>
+          <a:xfrm>
+            <a:off x="0" y="-1"/>
+            <a:ext cx="12188825" cy="618565"/>
+          </a:xfrm>
+          <a:prstGeom prst="rect">
+            <a:avLst/>
+          </a:prstGeom>
+          <a:solidFill>
+            <a:srgbClr val="EE0000"/>
+          </a:solidFill>
+          <a:ln>
+            <a:noFill/>
+          </a:ln>
+        </p:spPr>
+        <p:style>
+          <a:lnRef idx="1">
+            <a:schemeClr val="accent1"/>
+          </a:lnRef>
+          <a:fillRef idx="3">
+            <a:schemeClr val="accent1"/>
+          </a:fillRef>
+          <a:effectRef idx="2">
+            <a:schemeClr val="accent1"/>
+          </a:effectRef>
+          <a:fontRef idx="minor">
+            <a:schemeClr val="lt1"/>
+          </a:fontRef>
+        </p:style>
+        <p:txBody>
+          <a:bodyPr rtlCol="0" anchor="ctr"/>
+          <a:lstStyle/>
+          <a:p>
+            <a:pPr algn="ctr"/>
+            <a:endParaRPr/>
+          </a:p>
+        </p:txBody>
+      </p:sp>
+      <p:sp>
+        <p:nvSpPr>
+          <p:cNvPr id="3" name="TextBox 2"/>
+          <p:cNvSpPr txBox="1"/>
+          <p:nvPr/>
+        </p:nvSpPr>
+        <p:spPr>
+          <a:xfrm>
+            <a:off x="2895393" y="45720"/>
+            <a:ext cx="6096413" cy="523220"/>
+          </a:xfrm>
+          <a:prstGeom prst="rect">
+            <a:avLst/>
+          </a:prstGeom>
+          <a:noFill/>
+        </p:spPr>
+        <p:txBody>
+          <a:bodyPr wrap="none">
+            <a:spAutoFit/>
+          </a:bodyPr>
+          <a:lstStyle/>
+          <a:p>
+            <a:pPr algn="ctr">
+              <a:defRPr sz="2800" b="1">
+                <a:solidFill>
+                  <a:srgbClr val="FFFFFF"/>
+                </a:solidFill>
+              </a:defRPr>
+            </a:pPr>
+            <a:r>
+              <a:rPr dirty="0"/>
+              <a:t>Infrastructure &amp; Resource Management</a:t>
+            </a:r>
+          </a:p>
+        </p:txBody>
+      </p:sp>
+      <p:sp>
+        <p:nvSpPr>
+          <p:cNvPr id="4" name="Rounded Rectangle 3"/>
+          <p:cNvSpPr/>
+          <p:nvPr/>
+        </p:nvSpPr>
+        <p:spPr>
+          <a:xfrm>
+            <a:off x="914400" y="1828800"/>
+            <a:ext cx="5029200" cy="4114800"/>
+          </a:xfrm>
+          <a:prstGeom prst="roundRect">
+            <a:avLst/>
+          </a:prstGeom>
+          <a:solidFill>
+            <a:srgbClr val="E6F0FF"/>
+          </a:solidFill>
+          <a:ln w="25400">
+            <a:solidFill>
+              <a:srgbClr val="0066CC"/>
+            </a:solidFill>
+          </a:ln>
+        </p:spPr>
+        <p:style>
+          <a:lnRef idx="1">
+            <a:schemeClr val="accent1"/>
+          </a:lnRef>
+          <a:fillRef idx="3">
+            <a:schemeClr val="accent1"/>
+          </a:fillRef>
+          <a:effectRef idx="2">
+            <a:schemeClr val="accent1"/>
+          </a:effectRef>
+          <a:fontRef idx="minor">
+            <a:schemeClr val="lt1"/>
+          </a:fontRef>
+        </p:style>
+        <p:txBody>
+          <a:bodyPr rtlCol="0" anchor="ctr"/>
+          <a:lstStyle/>
+          <a:p>
+            <a:pPr algn="ctr"/>
+            <a:endParaRPr/>
+          </a:p>
+        </p:txBody>
+      </p:sp>
+      <p:sp>
+        <p:nvSpPr>
+          <p:cNvPr id="5" name="TextBox 4"/>
+          <p:cNvSpPr txBox="1"/>
+          <p:nvPr/>
+        </p:nvSpPr>
+        <p:spPr>
+          <a:xfrm>
+            <a:off x="1188720" y="2011680"/>
+            <a:ext cx="4572000" cy="457200"/>
+          </a:xfrm>
+          <a:prstGeom prst="rect">
+            <a:avLst/>
+          </a:prstGeom>
+          <a:noFill/>
+        </p:spPr>
+        <p:txBody>
+          <a:bodyPr wrap="none">
+            <a:spAutoFit/>
+          </a:bodyPr>
+          <a:lstStyle/>
+          <a:p>
+            <a:pPr>
+              <a:defRPr sz="2200" b="1">
+                <a:solidFill>
+                  <a:srgbClr val="0066CC"/>
+                </a:solidFill>
+              </a:defRPr>
+            </a:pPr>
+            <a:r>
+              <a:t>OpenShift Container Platform</a:t>
+            </a:r>
+          </a:p>
+        </p:txBody>
+      </p:sp>
+      <p:sp>
+        <p:nvSpPr>
+          <p:cNvPr id="6" name="TextBox 5"/>
+          <p:cNvSpPr txBox="1"/>
+          <p:nvPr/>
+        </p:nvSpPr>
+        <p:spPr>
+          <a:xfrm>
+            <a:off x="1371600" y="2743200"/>
+            <a:ext cx="4572000" cy="1954381"/>
+          </a:xfrm>
+          <a:prstGeom prst="rect">
+            <a:avLst/>
+          </a:prstGeom>
+          <a:noFill/>
+        </p:spPr>
+        <p:txBody>
+          <a:bodyPr wrap="square">
+            <a:spAutoFit/>
+          </a:bodyPr>
+          <a:lstStyle/>
+          <a:p>
+            <a:pPr>
+              <a:spcAft>
+                <a:spcPts val="600"/>
+              </a:spcAft>
+              <a:defRPr sz="1400">
+                <a:solidFill>
+                  <a:srgbClr val="000000"/>
+                </a:solidFill>
+              </a:defRPr>
+            </a:pPr>
+            <a:r>
+              <a:rPr sz="1600" dirty="0"/>
+              <a:t>✓ Namespace Isolation (iso-platform, </a:t>
+            </a:r>
+            <a:r>
+              <a:rPr sz="1600" dirty="0" err="1"/>
+              <a:t>llm</a:t>
+            </a:r>
+            <a:r>
+              <a:rPr sz="1600" dirty="0"/>
+              <a:t>, </a:t>
+            </a:r>
+            <a:r>
+              <a:rPr sz="1600" dirty="0" err="1"/>
+              <a:t>grafana</a:t>
+            </a:r>
+            <a:r>
+              <a:rPr sz="1600" dirty="0"/>
+              <a:t>)</a:t>
+            </a:r>
+          </a:p>
+          <a:p>
+            <a:pPr>
+              <a:spcAft>
+                <a:spcPts val="600"/>
+              </a:spcAft>
+              <a:defRPr sz="1400">
+                <a:solidFill>
+                  <a:srgbClr val="000000"/>
+                </a:solidFill>
+              </a:defRPr>
+            </a:pPr>
+            <a:r>
+              <a:rPr sz="1600" dirty="0"/>
+              <a:t>✓ RBAC &amp; </a:t>
+            </a:r>
+            <a:r>
+              <a:rPr sz="1600" dirty="0" err="1"/>
+              <a:t>ServiceAccounts</a:t>
+            </a:r>
+            <a:endParaRPr sz="1600" dirty="0"/>
+          </a:p>
+          <a:p>
+            <a:pPr>
+              <a:spcAft>
+                <a:spcPts val="600"/>
+              </a:spcAft>
+              <a:defRPr sz="1400">
+                <a:solidFill>
+                  <a:srgbClr val="000000"/>
+                </a:solidFill>
+              </a:defRPr>
+            </a:pPr>
+            <a:r>
+              <a:rPr sz="1600" dirty="0"/>
+              <a:t>✓ Routes (TLS edge termination)</a:t>
+            </a:r>
+          </a:p>
+          <a:p>
+            <a:pPr>
+              <a:spcAft>
+                <a:spcPts val="600"/>
+              </a:spcAft>
+              <a:defRPr sz="1400">
+                <a:solidFill>
+                  <a:srgbClr val="000000"/>
+                </a:solidFill>
+              </a:defRPr>
+            </a:pPr>
+            <a:r>
+              <a:rPr sz="1600" dirty="0"/>
+              <a:t>✓ GPU Node Scheduling (L40 48GB VRAM)</a:t>
+            </a:r>
+          </a:p>
+          <a:p>
+            <a:pPr>
+              <a:spcAft>
+                <a:spcPts val="600"/>
+              </a:spcAft>
+              <a:defRPr sz="1400">
+                <a:solidFill>
+                  <a:srgbClr val="000000"/>
+                </a:solidFill>
+              </a:defRPr>
+            </a:pPr>
+            <a:r>
+              <a:rPr sz="1600" dirty="0"/>
+              <a:t>✓ </a:t>
+            </a:r>
+            <a:r>
+              <a:rPr sz="1600" dirty="0" err="1"/>
+              <a:t>StatefulSets</a:t>
+            </a:r>
+            <a:r>
+              <a:rPr sz="1600" dirty="0"/>
+              <a:t> (PostgreSQL + </a:t>
+            </a:r>
+            <a:r>
+              <a:rPr sz="1600" dirty="0" err="1"/>
+              <a:t>pgvector</a:t>
+            </a:r>
+            <a:r>
+              <a:rPr sz="1600" dirty="0"/>
+              <a:t>)</a:t>
+            </a:r>
+          </a:p>
+          <a:p>
+            <a:pPr>
+              <a:spcAft>
+                <a:spcPts val="600"/>
+              </a:spcAft>
+              <a:defRPr sz="1400">
+                <a:solidFill>
+                  <a:srgbClr val="000000"/>
+                </a:solidFill>
+              </a:defRPr>
+            </a:pPr>
+            <a:r>
+              <a:rPr sz="1600" dirty="0"/>
+              <a:t>✓ </a:t>
+            </a:r>
+            <a:r>
+              <a:rPr sz="1600" dirty="0" err="1"/>
+              <a:t>ConfigMaps</a:t>
+            </a:r>
+            <a:r>
+              <a:rPr sz="1600" dirty="0"/>
+              <a:t> &amp; Secrets Management</a:t>
+            </a:r>
+          </a:p>
+        </p:txBody>
+      </p:sp>
+      <p:sp>
+        <p:nvSpPr>
+          <p:cNvPr id="7" name="Rounded Rectangle 6"/>
+          <p:cNvSpPr/>
+          <p:nvPr/>
+        </p:nvSpPr>
+        <p:spPr>
+          <a:xfrm>
+            <a:off x="6400800" y="1828800"/>
+            <a:ext cx="5029200" cy="4114800"/>
+          </a:xfrm>
+          <a:prstGeom prst="roundRect">
+            <a:avLst/>
+          </a:prstGeom>
+          <a:solidFill>
+            <a:srgbClr val="FFF0F0"/>
+          </a:solidFill>
+          <a:ln w="25400">
+            <a:solidFill>
+              <a:srgbClr val="EE0000"/>
+            </a:solidFill>
+          </a:ln>
+        </p:spPr>
+        <p:style>
+          <a:lnRef idx="1">
+            <a:schemeClr val="accent1"/>
+          </a:lnRef>
+          <a:fillRef idx="3">
+            <a:schemeClr val="accent1"/>
+          </a:fillRef>
+          <a:effectRef idx="2">
+            <a:schemeClr val="accent1"/>
+          </a:effectRef>
+          <a:fontRef idx="minor">
+            <a:schemeClr val="lt1"/>
+          </a:fontRef>
+        </p:style>
+        <p:txBody>
+          <a:bodyPr rtlCol="0" anchor="ctr"/>
+          <a:lstStyle/>
+          <a:p>
+            <a:pPr algn="ctr"/>
+            <a:endParaRPr/>
+          </a:p>
+        </p:txBody>
+      </p:sp>
+      <p:sp>
+        <p:nvSpPr>
+          <p:cNvPr id="8" name="TextBox 7"/>
+          <p:cNvSpPr txBox="1"/>
+          <p:nvPr/>
+        </p:nvSpPr>
+        <p:spPr>
+          <a:xfrm>
+            <a:off x="6675120" y="2011680"/>
+            <a:ext cx="4572000" cy="457200"/>
+          </a:xfrm>
+          <a:prstGeom prst="rect">
+            <a:avLst/>
+          </a:prstGeom>
+          <a:noFill/>
+        </p:spPr>
+        <p:txBody>
+          <a:bodyPr wrap="none">
+            <a:spAutoFit/>
+          </a:bodyPr>
+          <a:lstStyle/>
+          <a:p>
+            <a:pPr>
+              <a:defRPr sz="2200" b="1">
+                <a:solidFill>
+                  <a:srgbClr val="EE0000"/>
+                </a:solidFill>
+              </a:defRPr>
+            </a:pPr>
+            <a:r>
+              <a:t>Red Hat OpenShift AI Operator</a:t>
+            </a:r>
+          </a:p>
+        </p:txBody>
+      </p:sp>
+      <p:sp>
+        <p:nvSpPr>
+          <p:cNvPr id="9" name="TextBox 8"/>
+          <p:cNvSpPr txBox="1"/>
+          <p:nvPr/>
+        </p:nvSpPr>
+        <p:spPr>
+          <a:xfrm>
+            <a:off x="6858000" y="2743200"/>
+            <a:ext cx="3818965" cy="1954381"/>
+          </a:xfrm>
+          <a:prstGeom prst="rect">
+            <a:avLst/>
+          </a:prstGeom>
+          <a:noFill/>
+        </p:spPr>
+        <p:txBody>
+          <a:bodyPr wrap="square">
+            <a:spAutoFit/>
+          </a:bodyPr>
+          <a:lstStyle/>
+          <a:p>
+            <a:pPr>
+              <a:spcAft>
+                <a:spcPts val="600"/>
+              </a:spcAft>
+              <a:defRPr sz="1400">
+                <a:solidFill>
+                  <a:srgbClr val="000000"/>
+                </a:solidFill>
+              </a:defRPr>
+            </a:pPr>
+            <a:r>
+              <a:rPr sz="1600" dirty="0"/>
+              <a:t>✓ Model Serving (</a:t>
+            </a:r>
+            <a:r>
+              <a:rPr sz="1600" dirty="0" err="1"/>
+              <a:t>KServe</a:t>
+            </a:r>
+            <a:r>
+              <a:rPr sz="1600" dirty="0"/>
+              <a:t>, </a:t>
+            </a:r>
+            <a:r>
+              <a:rPr sz="1600" dirty="0" err="1"/>
+              <a:t>vLLM</a:t>
+            </a:r>
+            <a:r>
+              <a:rPr sz="1600" dirty="0"/>
+              <a:t>)</a:t>
+            </a:r>
+          </a:p>
+          <a:p>
+            <a:pPr>
+              <a:spcAft>
+                <a:spcPts val="600"/>
+              </a:spcAft>
+              <a:defRPr sz="1400">
+                <a:solidFill>
+                  <a:srgbClr val="000000"/>
+                </a:solidFill>
+              </a:defRPr>
+            </a:pPr>
+            <a:r>
+              <a:rPr sz="1600" dirty="0"/>
+              <a:t>✓ </a:t>
+            </a:r>
+            <a:r>
+              <a:rPr sz="1600" dirty="0" err="1"/>
+              <a:t>MaaS</a:t>
+            </a:r>
+            <a:r>
+              <a:rPr sz="1600" dirty="0"/>
+              <a:t> Gateway (</a:t>
+            </a:r>
+            <a:r>
+              <a:rPr sz="1600" dirty="0" err="1"/>
+              <a:t>Kuadrant</a:t>
+            </a:r>
+            <a:r>
+              <a:rPr sz="1600" dirty="0"/>
+              <a:t> API </a:t>
+            </a:r>
+            <a:r>
+              <a:rPr sz="1600" dirty="0" err="1"/>
+              <a:t>mgmt</a:t>
+            </a:r>
+            <a:r>
+              <a:rPr sz="1600" dirty="0"/>
+              <a:t>)</a:t>
+            </a:r>
+          </a:p>
+          <a:p>
+            <a:pPr>
+              <a:spcAft>
+                <a:spcPts val="600"/>
+              </a:spcAft>
+              <a:defRPr sz="1400">
+                <a:solidFill>
+                  <a:srgbClr val="000000"/>
+                </a:solidFill>
+              </a:defRPr>
+            </a:pPr>
+            <a:r>
+              <a:rPr sz="1600" dirty="0"/>
+              <a:t>✓ </a:t>
+            </a:r>
+            <a:r>
+              <a:rPr sz="1600" dirty="0" err="1"/>
+              <a:t>TrustyAI</a:t>
+            </a:r>
+            <a:r>
+              <a:rPr sz="1600" dirty="0"/>
+              <a:t> Service (Observability)</a:t>
+            </a:r>
+          </a:p>
+          <a:p>
+            <a:pPr>
+              <a:spcAft>
+                <a:spcPts val="600"/>
+              </a:spcAft>
+              <a:defRPr sz="1400">
+                <a:solidFill>
+                  <a:srgbClr val="000000"/>
+                </a:solidFill>
+              </a:defRPr>
+            </a:pPr>
+            <a:r>
+              <a:rPr sz="1600" dirty="0"/>
+              <a:t>✓ Ray Operator (Distributed ML)</a:t>
+            </a:r>
+          </a:p>
+          <a:p>
+            <a:pPr>
+              <a:spcAft>
+                <a:spcPts val="600"/>
+              </a:spcAft>
+              <a:defRPr sz="1400">
+                <a:solidFill>
+                  <a:srgbClr val="000000"/>
+                </a:solidFill>
+              </a:defRPr>
+            </a:pPr>
+            <a:r>
+              <a:rPr sz="1600" dirty="0"/>
+              <a:t>✓ </a:t>
+            </a:r>
+            <a:r>
+              <a:rPr sz="1600" dirty="0" err="1"/>
+              <a:t>MLflow</a:t>
+            </a:r>
+            <a:r>
+              <a:rPr sz="1600" dirty="0"/>
+              <a:t> (Experiment Tracking)</a:t>
+            </a:r>
+          </a:p>
+          <a:p>
+            <a:pPr>
+              <a:spcAft>
+                <a:spcPts val="600"/>
+              </a:spcAft>
+              <a:defRPr sz="1400">
+                <a:solidFill>
+                  <a:srgbClr val="000000"/>
+                </a:solidFill>
+              </a:defRPr>
+            </a:pPr>
+            <a:r>
+              <a:rPr sz="1600" dirty="0"/>
+              <a:t>✓ Data Science Pipelines (</a:t>
+            </a:r>
+            <a:r>
+              <a:rPr sz="1600" dirty="0" err="1"/>
+              <a:t>Tekton</a:t>
+            </a:r>
+            <a:r>
+              <a:rPr sz="1600" dirty="0"/>
+              <a:t>)</a:t>
+            </a:r>
+          </a:p>
+        </p:txBody>
+      </p:sp>
+    </p:spTree>
+  </p:cSld>
+  <p:clrMapOvr>
+    <a:masterClrMapping/>
+  </p:clrMapOvr>
+</p:sld>
+</file>
+
+<file path=ppt/slides/slide7.xml><?xml version="1.0" encoding="utf-8"?>
 <p:sld xmlns:a="http://schemas.openxmlformats.org/drawingml/2006/main" xmlns:r="http://schemas.openxmlformats.org/officeDocument/2006/relationships" xmlns:p="http://schemas.openxmlformats.org/presentationml/2006/main">
   <p:cSld>
     <p:spTree>
@@ -11216,112 +11358,6 @@
         <p14:creationId xmlns:p14="http://schemas.microsoft.com/office/powerpoint/2010/main" val="3246841885"/>
       </p:ext>
     </p:extLst>
-  </p:cSld>
-  <p:clrMapOvr>
-    <a:masterClrMapping/>
-  </p:clrMapOvr>
-</p:sld>
-</file>
-
-<file path=ppt/slides/slide7.xml><?xml version="1.0" encoding="utf-8"?>
-<p:sld xmlns:a="http://schemas.openxmlformats.org/drawingml/2006/main" xmlns:r="http://schemas.openxmlformats.org/officeDocument/2006/relationships" xmlns:p="http://schemas.openxmlformats.org/presentationml/2006/main">
-  <p:cSld>
-    <p:spTree>
-      <p:nvGrpSpPr>
-        <p:cNvPr id="1" name=""/>
-        <p:cNvGrpSpPr/>
-        <p:nvPr/>
-      </p:nvGrpSpPr>
-      <p:grpSpPr>
-        <a:xfrm>
-          <a:off x="0" y="0"/>
-          <a:ext cx="0" cy="0"/>
-          <a:chOff x="0" y="0"/>
-          <a:chExt cx="0" cy="0"/>
-        </a:xfrm>
-      </p:grpSpPr>
-      <p:sp>
-        <p:nvSpPr>
-          <p:cNvPr id="2" name="Rectangle 1"/>
-          <p:cNvSpPr/>
-          <p:nvPr/>
-        </p:nvSpPr>
-        <p:spPr>
-          <a:xfrm>
-            <a:off x="0" y="-1"/>
-            <a:ext cx="12188825" cy="618565"/>
-          </a:xfrm>
-          <a:prstGeom prst="rect">
-            <a:avLst/>
-          </a:prstGeom>
-          <a:solidFill>
-            <a:srgbClr val="EE0000"/>
-          </a:solidFill>
-          <a:ln>
-            <a:noFill/>
-          </a:ln>
-        </p:spPr>
-        <p:style>
-          <a:lnRef idx="1">
-            <a:schemeClr val="accent1"/>
-          </a:lnRef>
-          <a:fillRef idx="3">
-            <a:schemeClr val="accent1"/>
-          </a:fillRef>
-          <a:effectRef idx="2">
-            <a:schemeClr val="accent1"/>
-          </a:effectRef>
-          <a:fontRef idx="minor">
-            <a:schemeClr val="lt1"/>
-          </a:fontRef>
-        </p:style>
-        <p:txBody>
-          <a:bodyPr rtlCol="0" anchor="ctr"/>
-          <a:lstStyle/>
-          <a:p>
-            <a:pPr algn="ctr"/>
-            <a:endParaRPr/>
-          </a:p>
-        </p:txBody>
-      </p:sp>
-      <p:sp>
-        <p:nvSpPr>
-          <p:cNvPr id="3" name="TextBox 2"/>
-          <p:cNvSpPr txBox="1"/>
-          <p:nvPr/>
-        </p:nvSpPr>
-        <p:spPr>
-          <a:xfrm>
-            <a:off x="4843239" y="45720"/>
-            <a:ext cx="2200732" cy="523220"/>
-          </a:xfrm>
-          <a:prstGeom prst="rect">
-            <a:avLst/>
-          </a:prstGeom>
-          <a:noFill/>
-        </p:spPr>
-        <p:txBody>
-          <a:bodyPr wrap="none">
-            <a:spAutoFit/>
-          </a:bodyPr>
-          <a:lstStyle/>
-          <a:p>
-            <a:pPr algn="ctr">
-              <a:defRPr sz="2800" b="1">
-                <a:solidFill>
-                  <a:srgbClr val="FFFFFF"/>
-                </a:solidFill>
-              </a:defRPr>
-            </a:pPr>
-            <a:r>
-              <a:rPr lang="en-US" dirty="0"/>
-              <a:t>Business case</a:t>
-            </a:r>
-            <a:endParaRPr dirty="0"/>
-          </a:p>
-        </p:txBody>
-      </p:sp>
-    </p:spTree>
   </p:cSld>
   <p:clrMapOvr>
     <a:masterClrMapping/>

</xml_diff>